<commit_message>
hw 4 folder added
</commit_message>
<xml_diff>
--- a/4293 Python26/Daniel's Labs/final_project/Final_project_python.pptx
+++ b/4293 Python26/Daniel's Labs/final_project/Final_project_python.pptx
@@ -1396,7 +1396,7 @@
                 </a:r>
                 <a:r>
                   <a:rPr lang="en-US" dirty="0"/>
-                  <a:t> It sets the zero point for all phase angles in the system. All other bus angles (δ) are measured relative to the slack bus angle of 0°. This makes the 	math consistent.</a:t>
+                  <a:t> It sets the zero point for all phase angles in the system. All other bus angles (δ) are measured relative to the slack bus angle of 0°. This makes the math consistent.</a:t>
                 </a:r>
               </a:p>
               <a:p>
@@ -1612,7 +1612,7 @@
                 </a:r>
                 <a:r>
                   <a:rPr lang="en-US" dirty="0"/>
-                  <a:t> at the beginning (before the Newton-Raphson loop starts) from the branch data. It never changes during the 	iterations. It is used in every iteration to compute currents from voltages</a:t>
+                  <a:t> at the beginning (before the Newton-Raphson loop starts) from the branch data. It never changes during the iterations. It is used in every iteration to compute currents from voltages</a:t>
                 </a:r>
                 <a:endParaRPr lang="en-US" sz="1100" b="1" dirty="0">
                   <a:effectLst/>

</xml_diff>